<commit_message>
updated icon and rebuild toolbox
</commit_message>
<xml_diff>
--- a/Design/ico-sysml-import.pptx
+++ b/Design/ico-sysml-import.pptx
@@ -6,6 +6,7 @@
   </p:sldMasterIdLst>
   <p:sldIdLst>
     <p:sldId id="256" r:id="rId2"/>
+    <p:sldId id="257" r:id="rId3"/>
   </p:sldIdLst>
   <p:sldSz cx="2743200" cy="2743200"/>
   <p:notesSz cx="6858000" cy="9144000"/>
@@ -243,7 +244,7 @@
           <a:p>
             <a:fld id="{F2DEBFF9-250A-4D6B-B7B3-3F1E7C2640FE}" type="datetimeFigureOut">
               <a:rPr lang="en-US" smtClean="0"/>
-              <a:t>3/25/2024</a:t>
+              <a:t>5/7/2024</a:t>
             </a:fld>
             <a:endParaRPr lang="en-US"/>
           </a:p>
@@ -413,7 +414,7 @@
           <a:p>
             <a:fld id="{F2DEBFF9-250A-4D6B-B7B3-3F1E7C2640FE}" type="datetimeFigureOut">
               <a:rPr lang="en-US" smtClean="0"/>
-              <a:t>3/25/2024</a:t>
+              <a:t>5/7/2024</a:t>
             </a:fld>
             <a:endParaRPr lang="en-US"/>
           </a:p>
@@ -593,7 +594,7 @@
           <a:p>
             <a:fld id="{F2DEBFF9-250A-4D6B-B7B3-3F1E7C2640FE}" type="datetimeFigureOut">
               <a:rPr lang="en-US" smtClean="0"/>
-              <a:t>3/25/2024</a:t>
+              <a:t>5/7/2024</a:t>
             </a:fld>
             <a:endParaRPr lang="en-US"/>
           </a:p>
@@ -763,7 +764,7 @@
           <a:p>
             <a:fld id="{F2DEBFF9-250A-4D6B-B7B3-3F1E7C2640FE}" type="datetimeFigureOut">
               <a:rPr lang="en-US" smtClean="0"/>
-              <a:t>3/25/2024</a:t>
+              <a:t>5/7/2024</a:t>
             </a:fld>
             <a:endParaRPr lang="en-US"/>
           </a:p>
@@ -1007,7 +1008,7 @@
           <a:p>
             <a:fld id="{F2DEBFF9-250A-4D6B-B7B3-3F1E7C2640FE}" type="datetimeFigureOut">
               <a:rPr lang="en-US" smtClean="0"/>
-              <a:t>3/25/2024</a:t>
+              <a:t>5/7/2024</a:t>
             </a:fld>
             <a:endParaRPr lang="en-US"/>
           </a:p>
@@ -1239,7 +1240,7 @@
           <a:p>
             <a:fld id="{F2DEBFF9-250A-4D6B-B7B3-3F1E7C2640FE}" type="datetimeFigureOut">
               <a:rPr lang="en-US" smtClean="0"/>
-              <a:t>3/25/2024</a:t>
+              <a:t>5/7/2024</a:t>
             </a:fld>
             <a:endParaRPr lang="en-US"/>
           </a:p>
@@ -1606,7 +1607,7 @@
           <a:p>
             <a:fld id="{F2DEBFF9-250A-4D6B-B7B3-3F1E7C2640FE}" type="datetimeFigureOut">
               <a:rPr lang="en-US" smtClean="0"/>
-              <a:t>3/25/2024</a:t>
+              <a:t>5/7/2024</a:t>
             </a:fld>
             <a:endParaRPr lang="en-US"/>
           </a:p>
@@ -1724,7 +1725,7 @@
           <a:p>
             <a:fld id="{F2DEBFF9-250A-4D6B-B7B3-3F1E7C2640FE}" type="datetimeFigureOut">
               <a:rPr lang="en-US" smtClean="0"/>
-              <a:t>3/25/2024</a:t>
+              <a:t>5/7/2024</a:t>
             </a:fld>
             <a:endParaRPr lang="en-US"/>
           </a:p>
@@ -1819,7 +1820,7 @@
           <a:p>
             <a:fld id="{F2DEBFF9-250A-4D6B-B7B3-3F1E7C2640FE}" type="datetimeFigureOut">
               <a:rPr lang="en-US" smtClean="0"/>
-              <a:t>3/25/2024</a:t>
+              <a:t>5/7/2024</a:t>
             </a:fld>
             <a:endParaRPr lang="en-US"/>
           </a:p>
@@ -2096,7 +2097,7 @@
           <a:p>
             <a:fld id="{F2DEBFF9-250A-4D6B-B7B3-3F1E7C2640FE}" type="datetimeFigureOut">
               <a:rPr lang="en-US" smtClean="0"/>
-              <a:t>3/25/2024</a:t>
+              <a:t>5/7/2024</a:t>
             </a:fld>
             <a:endParaRPr lang="en-US"/>
           </a:p>
@@ -2353,7 +2354,7 @@
           <a:p>
             <a:fld id="{F2DEBFF9-250A-4D6B-B7B3-3F1E7C2640FE}" type="datetimeFigureOut">
               <a:rPr lang="en-US" smtClean="0"/>
-              <a:t>3/25/2024</a:t>
+              <a:t>5/7/2024</a:t>
             </a:fld>
             <a:endParaRPr lang="en-US"/>
           </a:p>
@@ -2566,7 +2567,7 @@
           <a:p>
             <a:fld id="{F2DEBFF9-250A-4D6B-B7B3-3F1E7C2640FE}" type="datetimeFigureOut">
               <a:rPr lang="en-US" smtClean="0"/>
-              <a:t>3/25/2024</a:t>
+              <a:t>5/7/2024</a:t>
             </a:fld>
             <a:endParaRPr lang="en-US"/>
           </a:p>
@@ -2962,7 +2963,7 @@
         <a:gradFill flip="none" rotWithShape="1">
           <a:gsLst>
             <a:gs pos="22000">
-              <a:srgbClr val="4B4B4B"/>
+              <a:schemeClr val="accent5"/>
             </a:gs>
             <a:gs pos="0">
               <a:schemeClr val="accent4">
@@ -2971,7 +2972,9 @@
               </a:schemeClr>
             </a:gs>
             <a:gs pos="100000">
-              <a:schemeClr val="tx1"/>
+              <a:schemeClr val="tx2">
+                <a:lumMod val="50000"/>
+              </a:schemeClr>
             </a:gs>
           </a:gsLst>
           <a:path path="circle">
@@ -2998,6 +3001,149 @@
       </p:grpSpPr>
       <p:sp>
         <p:nvSpPr>
+          <p:cNvPr id="18" name="Rectangle: Folded Corner 17">
+            <a:extLst>
+              <a:ext uri="{FF2B5EF4-FFF2-40B4-BE49-F238E27FC236}">
+                <a16:creationId xmlns:a16="http://schemas.microsoft.com/office/drawing/2014/main" id="{01678692-3754-FEEA-7C6B-BD8B67F32234}"/>
+              </a:ext>
+            </a:extLst>
+          </p:cNvPr>
+          <p:cNvSpPr/>
+          <p:nvPr/>
+        </p:nvSpPr>
+        <p:spPr>
+          <a:xfrm rot="10800000" flipH="1">
+            <a:off x="341591" y="959157"/>
+            <a:ext cx="606474" cy="802813"/>
+          </a:xfrm>
+          <a:prstGeom prst="foldedCorner">
+            <a:avLst>
+              <a:gd name="adj" fmla="val 41988"/>
+            </a:avLst>
+          </a:prstGeom>
+          <a:solidFill>
+            <a:schemeClr val="bg1"/>
+          </a:solidFill>
+        </p:spPr>
+        <p:style>
+          <a:lnRef idx="2">
+            <a:schemeClr val="accent1">
+              <a:shade val="15000"/>
+            </a:schemeClr>
+          </a:lnRef>
+          <a:fillRef idx="1">
+            <a:schemeClr val="accent1"/>
+          </a:fillRef>
+          <a:effectRef idx="0">
+            <a:schemeClr val="accent1"/>
+          </a:effectRef>
+          <a:fontRef idx="minor">
+            <a:schemeClr val="lt1"/>
+          </a:fontRef>
+        </p:style>
+        <p:txBody>
+          <a:bodyPr rtlCol="0" anchor="ctr"/>
+          <a:lstStyle/>
+          <a:p>
+            <a:pPr algn="ctr"/>
+            <a:endParaRPr lang="en-US"/>
+          </a:p>
+        </p:txBody>
+      </p:sp>
+      <p:sp>
+        <p:nvSpPr>
+          <p:cNvPr id="8" name="Rectangle: Folded Corner 7">
+            <a:extLst>
+              <a:ext uri="{FF2B5EF4-FFF2-40B4-BE49-F238E27FC236}">
+                <a16:creationId xmlns:a16="http://schemas.microsoft.com/office/drawing/2014/main" id="{F85668A9-32D2-7167-C325-F9ECECCE9C32}"/>
+              </a:ext>
+            </a:extLst>
+          </p:cNvPr>
+          <p:cNvSpPr/>
+          <p:nvPr/>
+        </p:nvSpPr>
+        <p:spPr>
+          <a:xfrm rot="10800000" flipH="1">
+            <a:off x="251316" y="1008906"/>
+            <a:ext cx="606474" cy="802813"/>
+          </a:xfrm>
+          <a:prstGeom prst="foldedCorner">
+            <a:avLst>
+              <a:gd name="adj" fmla="val 41988"/>
+            </a:avLst>
+          </a:prstGeom>
+          <a:solidFill>
+            <a:schemeClr val="bg1"/>
+          </a:solidFill>
+        </p:spPr>
+        <p:style>
+          <a:lnRef idx="2">
+            <a:schemeClr val="accent1">
+              <a:shade val="15000"/>
+            </a:schemeClr>
+          </a:lnRef>
+          <a:fillRef idx="1">
+            <a:schemeClr val="accent1"/>
+          </a:fillRef>
+          <a:effectRef idx="0">
+            <a:schemeClr val="accent1"/>
+          </a:effectRef>
+          <a:fontRef idx="minor">
+            <a:schemeClr val="lt1"/>
+          </a:fontRef>
+        </p:style>
+        <p:txBody>
+          <a:bodyPr rtlCol="0" anchor="ctr"/>
+          <a:lstStyle/>
+          <a:p>
+            <a:pPr algn="ctr"/>
+            <a:endParaRPr lang="en-US"/>
+          </a:p>
+        </p:txBody>
+      </p:sp>
+      <p:sp>
+        <p:nvSpPr>
+          <p:cNvPr id="21" name="TextBox 20">
+            <a:extLst>
+              <a:ext uri="{FF2B5EF4-FFF2-40B4-BE49-F238E27FC236}">
+                <a16:creationId xmlns:a16="http://schemas.microsoft.com/office/drawing/2014/main" id="{F20193A0-20E5-EE78-85FC-F72CC286E722}"/>
+              </a:ext>
+            </a:extLst>
+          </p:cNvPr>
+          <p:cNvSpPr txBox="1"/>
+          <p:nvPr/>
+        </p:nvSpPr>
+        <p:spPr>
+          <a:xfrm>
+            <a:off x="-37283" y="2166424"/>
+            <a:ext cx="2653290" cy="584775"/>
+          </a:xfrm>
+          <a:prstGeom prst="rect">
+            <a:avLst/>
+          </a:prstGeom>
+          <a:noFill/>
+        </p:spPr>
+        <p:txBody>
+          <a:bodyPr wrap="none" rtlCol="0">
+            <a:spAutoFit/>
+          </a:bodyPr>
+          <a:lstStyle/>
+          <a:p>
+            <a:pPr algn="ctr"/>
+            <a:r>
+              <a:rPr lang="en-US" sz="3200" b="1" dirty="0">
+                <a:solidFill>
+                  <a:srgbClr val="C55A11"/>
+                </a:solidFill>
+                <a:latin typeface="Lucida Sans Typewriter" panose="020B0509030504030204" pitchFamily="49" charset="0"/>
+              </a:rPr>
+              <a:t> Connector</a:t>
+            </a:r>
+          </a:p>
+        </p:txBody>
+      </p:sp>
+      <p:sp>
+        <p:nvSpPr>
           <p:cNvPr id="27" name="Rectangle: Folded Corner 26">
             <a:extLst>
               <a:ext uri="{FF2B5EF4-FFF2-40B4-BE49-F238E27FC236}">
@@ -3010,7 +3156,7 @@
         </p:nvSpPr>
         <p:spPr>
           <a:xfrm rot="10800000" flipH="1">
-            <a:off x="125615" y="1054521"/>
+            <a:off x="125615" y="1059279"/>
             <a:ext cx="606474" cy="802813"/>
           </a:xfrm>
           <a:prstGeom prst="foldedCorner">
@@ -3543,6 +3689,837 @@
         </p:nvSpPr>
         <p:spPr>
           <a:xfrm>
+            <a:off x="911822" y="1099551"/>
+            <a:ext cx="846250" cy="662419"/>
+          </a:xfrm>
+          <a:prstGeom prst="rightArrow">
+            <a:avLst>
+              <a:gd name="adj1" fmla="val 54249"/>
+              <a:gd name="adj2" fmla="val 57182"/>
+            </a:avLst>
+          </a:prstGeom>
+          <a:solidFill>
+            <a:schemeClr val="bg1"/>
+          </a:solidFill>
+          <a:ln w="76200">
+            <a:solidFill>
+              <a:schemeClr val="accent2">
+                <a:lumMod val="75000"/>
+              </a:schemeClr>
+            </a:solidFill>
+          </a:ln>
+        </p:spPr>
+        <p:style>
+          <a:lnRef idx="2">
+            <a:schemeClr val="accent1">
+              <a:shade val="15000"/>
+            </a:schemeClr>
+          </a:lnRef>
+          <a:fillRef idx="1">
+            <a:schemeClr val="accent1"/>
+          </a:fillRef>
+          <a:effectRef idx="0">
+            <a:schemeClr val="accent1"/>
+          </a:effectRef>
+          <a:fontRef idx="minor">
+            <a:schemeClr val="lt1"/>
+          </a:fontRef>
+        </p:style>
+        <p:txBody>
+          <a:bodyPr rtlCol="0" anchor="ctr"/>
+          <a:lstStyle/>
+          <a:p>
+            <a:pPr algn="ctr"/>
+            <a:endParaRPr lang="en-US"/>
+          </a:p>
+        </p:txBody>
+      </p:sp>
+      <p:sp>
+        <p:nvSpPr>
+          <p:cNvPr id="9" name="TextBox 8">
+            <a:extLst>
+              <a:ext uri="{FF2B5EF4-FFF2-40B4-BE49-F238E27FC236}">
+                <a16:creationId xmlns:a16="http://schemas.microsoft.com/office/drawing/2014/main" id="{CC0F99FF-6A97-633B-F263-6CBF7595DB83}"/>
+              </a:ext>
+            </a:extLst>
+          </p:cNvPr>
+          <p:cNvSpPr txBox="1"/>
+          <p:nvPr/>
+        </p:nvSpPr>
+        <p:spPr>
+          <a:xfrm>
+            <a:off x="85130" y="1850296"/>
+            <a:ext cx="1579279" cy="646331"/>
+          </a:xfrm>
+          <a:prstGeom prst="rect">
+            <a:avLst/>
+          </a:prstGeom>
+          <a:noFill/>
+        </p:spPr>
+        <p:txBody>
+          <a:bodyPr wrap="none" rtlCol="0">
+            <a:spAutoFit/>
+          </a:bodyPr>
+          <a:lstStyle/>
+          <a:p>
+            <a:pPr algn="ctr">
+              <a:spcAft>
+                <a:spcPts val="1200"/>
+              </a:spcAft>
+            </a:pPr>
+            <a:r>
+              <a:rPr lang="en-US" sz="3600" b="1" dirty="0">
+                <a:solidFill>
+                  <a:schemeClr val="bg1"/>
+                </a:solidFill>
+                <a:latin typeface="Lucida Sans Typewriter" panose="020B0509030504030204" pitchFamily="49" charset="0"/>
+              </a:rPr>
+              <a:t>SysML</a:t>
+            </a:r>
+          </a:p>
+        </p:txBody>
+      </p:sp>
+      <p:sp>
+        <p:nvSpPr>
+          <p:cNvPr id="25" name="Rectangle 24">
+            <a:extLst>
+              <a:ext uri="{FF2B5EF4-FFF2-40B4-BE49-F238E27FC236}">
+                <a16:creationId xmlns:a16="http://schemas.microsoft.com/office/drawing/2014/main" id="{35268278-3D16-6CD3-7C25-F821A41103D3}"/>
+              </a:ext>
+            </a:extLst>
+          </p:cNvPr>
+          <p:cNvSpPr/>
+          <p:nvPr/>
+        </p:nvSpPr>
+        <p:spPr>
+          <a:xfrm>
+            <a:off x="52389" y="1360564"/>
+            <a:ext cx="753842" cy="343996"/>
+          </a:xfrm>
+          <a:prstGeom prst="rect">
+            <a:avLst/>
+          </a:prstGeom>
+          <a:solidFill>
+            <a:schemeClr val="bg1"/>
+          </a:solidFill>
+        </p:spPr>
+        <p:style>
+          <a:lnRef idx="2">
+            <a:schemeClr val="accent1">
+              <a:shade val="15000"/>
+            </a:schemeClr>
+          </a:lnRef>
+          <a:fillRef idx="1">
+            <a:schemeClr val="accent1"/>
+          </a:fillRef>
+          <a:effectRef idx="0">
+            <a:schemeClr val="accent1"/>
+          </a:effectRef>
+          <a:fontRef idx="minor">
+            <a:schemeClr val="lt1"/>
+          </a:fontRef>
+        </p:style>
+        <p:txBody>
+          <a:bodyPr rtlCol="0" anchor="ctr"/>
+          <a:lstStyle/>
+          <a:p>
+            <a:pPr algn="ctr"/>
+            <a:r>
+              <a:rPr lang="en-US" sz="2400" b="1" dirty="0">
+                <a:solidFill>
+                  <a:sysClr val="windowText" lastClr="000000"/>
+                </a:solidFill>
+                <a:latin typeface="Lucida Sans Typewriter" panose="020B0509030504030204" pitchFamily="49" charset="0"/>
+              </a:rPr>
+              <a:t>XMI</a:t>
+            </a:r>
+          </a:p>
+        </p:txBody>
+      </p:sp>
+      <p:sp>
+        <p:nvSpPr>
+          <p:cNvPr id="41" name="TextBox 40">
+            <a:extLst>
+              <a:ext uri="{FF2B5EF4-FFF2-40B4-BE49-F238E27FC236}">
+                <a16:creationId xmlns:a16="http://schemas.microsoft.com/office/drawing/2014/main" id="{5AA8629A-4491-D68D-0764-583A854EDA97}"/>
+              </a:ext>
+            </a:extLst>
+          </p:cNvPr>
+          <p:cNvSpPr txBox="1"/>
+          <p:nvPr/>
+        </p:nvSpPr>
+        <p:spPr>
+          <a:xfrm>
+            <a:off x="-26690" y="-30778"/>
+            <a:ext cx="1665841" cy="584775"/>
+          </a:xfrm>
+          <a:prstGeom prst="rect">
+            <a:avLst/>
+          </a:prstGeom>
+          <a:noFill/>
+        </p:spPr>
+        <p:txBody>
+          <a:bodyPr wrap="none" rtlCol="0">
+            <a:spAutoFit/>
+          </a:bodyPr>
+          <a:lstStyle/>
+          <a:p>
+            <a:pPr algn="ctr"/>
+            <a:r>
+              <a:rPr lang="en-US" sz="3200" dirty="0">
+                <a:solidFill>
+                  <a:schemeClr val="bg1"/>
+                </a:solidFill>
+                <a:latin typeface="Lucida Sans Typewriter" panose="020B0509030504030204" pitchFamily="49" charset="0"/>
+              </a:rPr>
+              <a:t>System</a:t>
+            </a:r>
+          </a:p>
+        </p:txBody>
+      </p:sp>
+      <p:sp>
+        <p:nvSpPr>
+          <p:cNvPr id="42" name="TextBox 41">
+            <a:extLst>
+              <a:ext uri="{FF2B5EF4-FFF2-40B4-BE49-F238E27FC236}">
+                <a16:creationId xmlns:a16="http://schemas.microsoft.com/office/drawing/2014/main" id="{D3D6A2CC-5DFF-6A90-BE47-6DAEF04917C0}"/>
+              </a:ext>
+            </a:extLst>
+          </p:cNvPr>
+          <p:cNvSpPr txBox="1"/>
+          <p:nvPr/>
+        </p:nvSpPr>
+        <p:spPr>
+          <a:xfrm>
+            <a:off x="456440" y="286974"/>
+            <a:ext cx="2159567" cy="584775"/>
+          </a:xfrm>
+          <a:prstGeom prst="rect">
+            <a:avLst/>
+          </a:prstGeom>
+          <a:noFill/>
+        </p:spPr>
+        <p:txBody>
+          <a:bodyPr wrap="none" rtlCol="0">
+            <a:spAutoFit/>
+          </a:bodyPr>
+          <a:lstStyle/>
+          <a:p>
+            <a:pPr algn="ctr"/>
+            <a:r>
+              <a:rPr lang="en-US" sz="3200" dirty="0">
+                <a:solidFill>
+                  <a:schemeClr val="bg1"/>
+                </a:solidFill>
+                <a:latin typeface="Lucida Sans Typewriter" panose="020B0509030504030204" pitchFamily="49" charset="0"/>
+              </a:rPr>
+              <a:t>Composer</a:t>
+            </a:r>
+          </a:p>
+        </p:txBody>
+      </p:sp>
+    </p:spTree>
+    <p:extLst>
+      <p:ext uri="{BB962C8B-B14F-4D97-AF65-F5344CB8AC3E}">
+        <p14:creationId xmlns:p14="http://schemas.microsoft.com/office/powerpoint/2010/main" val="98246"/>
+      </p:ext>
+    </p:extLst>
+  </p:cSld>
+  <p:clrMapOvr>
+    <a:masterClrMapping/>
+  </p:clrMapOvr>
+</p:sld>
+</file>
+
+<file path=ppt/slides/slide2.xml><?xml version="1.0" encoding="utf-8"?>
+<p:sld xmlns:a="http://schemas.openxmlformats.org/drawingml/2006/main" xmlns:r="http://schemas.openxmlformats.org/officeDocument/2006/relationships" xmlns:p="http://schemas.openxmlformats.org/presentationml/2006/main">
+  <p:cSld>
+    <p:bg>
+      <p:bgPr>
+        <a:gradFill flip="none" rotWithShape="1">
+          <a:gsLst>
+            <a:gs pos="22000">
+              <a:srgbClr val="4B4B4B"/>
+            </a:gs>
+            <a:gs pos="0">
+              <a:schemeClr val="accent4">
+                <a:lumMod val="0"/>
+                <a:lumOff val="100000"/>
+              </a:schemeClr>
+            </a:gs>
+            <a:gs pos="100000">
+              <a:schemeClr val="tx1"/>
+            </a:gs>
+          </a:gsLst>
+          <a:path path="circle">
+            <a:fillToRect l="50000" t="-80000" r="50000" b="180000"/>
+          </a:path>
+          <a:tileRect/>
+        </a:gradFill>
+        <a:effectLst/>
+      </p:bgPr>
+    </p:bg>
+    <p:spTree>
+      <p:nvGrpSpPr>
+        <p:cNvPr id="1" name=""/>
+        <p:cNvGrpSpPr/>
+        <p:nvPr/>
+      </p:nvGrpSpPr>
+      <p:grpSpPr>
+        <a:xfrm>
+          <a:off x="0" y="0"/>
+          <a:ext cx="0" cy="0"/>
+          <a:chOff x="0" y="0"/>
+          <a:chExt cx="0" cy="0"/>
+        </a:xfrm>
+      </p:grpSpPr>
+      <p:sp>
+        <p:nvSpPr>
+          <p:cNvPr id="27" name="Rectangle: Folded Corner 26">
+            <a:extLst>
+              <a:ext uri="{FF2B5EF4-FFF2-40B4-BE49-F238E27FC236}">
+                <a16:creationId xmlns:a16="http://schemas.microsoft.com/office/drawing/2014/main" id="{DF8DF1B3-0D25-6509-B36B-BE3B82F70C04}"/>
+              </a:ext>
+            </a:extLst>
+          </p:cNvPr>
+          <p:cNvSpPr/>
+          <p:nvPr/>
+        </p:nvSpPr>
+        <p:spPr>
+          <a:xfrm rot="10800000" flipH="1">
+            <a:off x="125615" y="1054521"/>
+            <a:ext cx="606474" cy="802813"/>
+          </a:xfrm>
+          <a:prstGeom prst="foldedCorner">
+            <a:avLst>
+              <a:gd name="adj" fmla="val 41988"/>
+            </a:avLst>
+          </a:prstGeom>
+          <a:solidFill>
+            <a:schemeClr val="bg1"/>
+          </a:solidFill>
+        </p:spPr>
+        <p:style>
+          <a:lnRef idx="2">
+            <a:schemeClr val="accent1">
+              <a:shade val="15000"/>
+            </a:schemeClr>
+          </a:lnRef>
+          <a:fillRef idx="1">
+            <a:schemeClr val="accent1"/>
+          </a:fillRef>
+          <a:effectRef idx="0">
+            <a:schemeClr val="accent1"/>
+          </a:effectRef>
+          <a:fontRef idx="minor">
+            <a:schemeClr val="lt1"/>
+          </a:fontRef>
+        </p:style>
+        <p:txBody>
+          <a:bodyPr rtlCol="0" anchor="ctr"/>
+          <a:lstStyle/>
+          <a:p>
+            <a:pPr algn="ctr"/>
+            <a:endParaRPr lang="en-US"/>
+          </a:p>
+        </p:txBody>
+      </p:sp>
+      <p:grpSp>
+        <p:nvGrpSpPr>
+          <p:cNvPr id="10" name="Group 9">
+            <a:extLst>
+              <a:ext uri="{FF2B5EF4-FFF2-40B4-BE49-F238E27FC236}">
+                <a16:creationId xmlns:a16="http://schemas.microsoft.com/office/drawing/2014/main" id="{8EE7CD5E-51D7-7281-EDF9-9423DDACDF37}"/>
+              </a:ext>
+            </a:extLst>
+          </p:cNvPr>
+          <p:cNvGrpSpPr/>
+          <p:nvPr/>
+        </p:nvGrpSpPr>
+        <p:grpSpPr>
+          <a:xfrm>
+            <a:off x="1709554" y="820624"/>
+            <a:ext cx="906453" cy="1118737"/>
+            <a:chOff x="3056554" y="3795139"/>
+            <a:chExt cx="532532" cy="657247"/>
+          </a:xfrm>
+        </p:grpSpPr>
+        <p:sp>
+          <p:nvSpPr>
+            <p:cNvPr id="11" name="Rectangle: Rounded Corners 10">
+              <a:extLst>
+                <a:ext uri="{FF2B5EF4-FFF2-40B4-BE49-F238E27FC236}">
+                  <a16:creationId xmlns:a16="http://schemas.microsoft.com/office/drawing/2014/main" id="{4D6CC072-0471-A6D6-8016-D6CF7BFE820D}"/>
+                </a:ext>
+              </a:extLst>
+            </p:cNvPr>
+            <p:cNvSpPr/>
+            <p:nvPr/>
+          </p:nvSpPr>
+          <p:spPr>
+            <a:xfrm>
+              <a:off x="3056554" y="3795139"/>
+              <a:ext cx="532532" cy="657247"/>
+            </a:xfrm>
+            <a:prstGeom prst="roundRect">
+              <a:avLst/>
+            </a:prstGeom>
+            <a:ln/>
+          </p:spPr>
+          <p:style>
+            <a:lnRef idx="2">
+              <a:schemeClr val="accent2"/>
+            </a:lnRef>
+            <a:fillRef idx="1">
+              <a:schemeClr val="lt1"/>
+            </a:fillRef>
+            <a:effectRef idx="0">
+              <a:schemeClr val="accent2"/>
+            </a:effectRef>
+            <a:fontRef idx="minor">
+              <a:schemeClr val="dk1"/>
+            </a:fontRef>
+          </p:style>
+          <p:txBody>
+            <a:bodyPr rtlCol="0" anchor="ctr"/>
+            <a:lstStyle/>
+            <a:p>
+              <a:pPr algn="ctr"/>
+              <a:endParaRPr lang="en-US" b="1">
+                <a:latin typeface="Arial" pitchFamily="34" charset="0"/>
+                <a:cs typeface="Arial" pitchFamily="34" charset="0"/>
+              </a:endParaRPr>
+            </a:p>
+          </p:txBody>
+        </p:sp>
+        <p:sp>
+          <p:nvSpPr>
+            <p:cNvPr id="12" name="Freeform: Shape 11">
+              <a:extLst>
+                <a:ext uri="{FF2B5EF4-FFF2-40B4-BE49-F238E27FC236}">
+                  <a16:creationId xmlns:a16="http://schemas.microsoft.com/office/drawing/2014/main" id="{997D5E48-094C-99F5-9235-7E505C595229}"/>
+                </a:ext>
+              </a:extLst>
+            </p:cNvPr>
+            <p:cNvSpPr/>
+            <p:nvPr/>
+          </p:nvSpPr>
+          <p:spPr>
+            <a:xfrm>
+              <a:off x="3176694" y="4109554"/>
+              <a:ext cx="292251" cy="85247"/>
+            </a:xfrm>
+            <a:custGeom>
+              <a:avLst/>
+              <a:gdLst>
+                <a:gd name="connsiteX0" fmla="*/ 159410 w 292251"/>
+                <a:gd name="connsiteY0" fmla="*/ 28416 h 85247"/>
+                <a:gd name="connsiteX1" fmla="*/ 159410 w 292251"/>
+                <a:gd name="connsiteY1" fmla="*/ 0 h 85247"/>
+                <a:gd name="connsiteX2" fmla="*/ 132841 w 292251"/>
+                <a:gd name="connsiteY2" fmla="*/ 0 h 85247"/>
+                <a:gd name="connsiteX3" fmla="*/ 132841 w 292251"/>
+                <a:gd name="connsiteY3" fmla="*/ 28416 h 85247"/>
+                <a:gd name="connsiteX4" fmla="*/ 0 w 292251"/>
+                <a:gd name="connsiteY4" fmla="*/ 28416 h 85247"/>
+                <a:gd name="connsiteX5" fmla="*/ 0 w 292251"/>
+                <a:gd name="connsiteY5" fmla="*/ 85247 h 85247"/>
+                <a:gd name="connsiteX6" fmla="*/ 26568 w 292251"/>
+                <a:gd name="connsiteY6" fmla="*/ 85247 h 85247"/>
+                <a:gd name="connsiteX7" fmla="*/ 26568 w 292251"/>
+                <a:gd name="connsiteY7" fmla="*/ 56832 h 85247"/>
+                <a:gd name="connsiteX8" fmla="*/ 265683 w 292251"/>
+                <a:gd name="connsiteY8" fmla="*/ 56832 h 85247"/>
+                <a:gd name="connsiteX9" fmla="*/ 265683 w 292251"/>
+                <a:gd name="connsiteY9" fmla="*/ 85247 h 85247"/>
+                <a:gd name="connsiteX10" fmla="*/ 292251 w 292251"/>
+                <a:gd name="connsiteY10" fmla="*/ 85247 h 85247"/>
+                <a:gd name="connsiteX11" fmla="*/ 292251 w 292251"/>
+                <a:gd name="connsiteY11" fmla="*/ 28416 h 85247"/>
+                <a:gd name="connsiteX12" fmla="*/ 159410 w 292251"/>
+                <a:gd name="connsiteY12" fmla="*/ 28416 h 85247"/>
+              </a:gdLst>
+              <a:ahLst/>
+              <a:cxnLst>
+                <a:cxn ang="0">
+                  <a:pos x="connsiteX0" y="connsiteY0"/>
+                </a:cxn>
+                <a:cxn ang="0">
+                  <a:pos x="connsiteX1" y="connsiteY1"/>
+                </a:cxn>
+                <a:cxn ang="0">
+                  <a:pos x="connsiteX2" y="connsiteY2"/>
+                </a:cxn>
+                <a:cxn ang="0">
+                  <a:pos x="connsiteX3" y="connsiteY3"/>
+                </a:cxn>
+                <a:cxn ang="0">
+                  <a:pos x="connsiteX4" y="connsiteY4"/>
+                </a:cxn>
+                <a:cxn ang="0">
+                  <a:pos x="connsiteX5" y="connsiteY5"/>
+                </a:cxn>
+                <a:cxn ang="0">
+                  <a:pos x="connsiteX6" y="connsiteY6"/>
+                </a:cxn>
+                <a:cxn ang="0">
+                  <a:pos x="connsiteX7" y="connsiteY7"/>
+                </a:cxn>
+                <a:cxn ang="0">
+                  <a:pos x="connsiteX8" y="connsiteY8"/>
+                </a:cxn>
+                <a:cxn ang="0">
+                  <a:pos x="connsiteX9" y="connsiteY9"/>
+                </a:cxn>
+                <a:cxn ang="0">
+                  <a:pos x="connsiteX10" y="connsiteY10"/>
+                </a:cxn>
+                <a:cxn ang="0">
+                  <a:pos x="connsiteX11" y="connsiteY11"/>
+                </a:cxn>
+                <a:cxn ang="0">
+                  <a:pos x="connsiteX12" y="connsiteY12"/>
+                </a:cxn>
+              </a:cxnLst>
+              <a:rect l="l" t="t" r="r" b="b"/>
+              <a:pathLst>
+                <a:path w="292251" h="85247">
+                  <a:moveTo>
+                    <a:pt x="159410" y="28416"/>
+                  </a:moveTo>
+                  <a:lnTo>
+                    <a:pt x="159410" y="0"/>
+                  </a:lnTo>
+                  <a:lnTo>
+                    <a:pt x="132841" y="0"/>
+                  </a:lnTo>
+                  <a:lnTo>
+                    <a:pt x="132841" y="28416"/>
+                  </a:lnTo>
+                  <a:lnTo>
+                    <a:pt x="0" y="28416"/>
+                  </a:lnTo>
+                  <a:lnTo>
+                    <a:pt x="0" y="85247"/>
+                  </a:lnTo>
+                  <a:lnTo>
+                    <a:pt x="26568" y="85247"/>
+                  </a:lnTo>
+                  <a:lnTo>
+                    <a:pt x="26568" y="56832"/>
+                  </a:lnTo>
+                  <a:lnTo>
+                    <a:pt x="265683" y="56832"/>
+                  </a:lnTo>
+                  <a:lnTo>
+                    <a:pt x="265683" y="85247"/>
+                  </a:lnTo>
+                  <a:lnTo>
+                    <a:pt x="292251" y="85247"/>
+                  </a:lnTo>
+                  <a:lnTo>
+                    <a:pt x="292251" y="28416"/>
+                  </a:lnTo>
+                  <a:lnTo>
+                    <a:pt x="159410" y="28416"/>
+                  </a:lnTo>
+                  <a:close/>
+                </a:path>
+              </a:pathLst>
+            </a:custGeom>
+            <a:solidFill>
+              <a:srgbClr val="FFFFFF"/>
+            </a:solidFill>
+            <a:ln w="26334" cap="flat">
+              <a:noFill/>
+              <a:prstDash val="solid"/>
+              <a:miter/>
+            </a:ln>
+          </p:spPr>
+          <p:txBody>
+            <a:bodyPr rtlCol="0" anchor="ctr"/>
+            <a:lstStyle/>
+            <a:p>
+              <a:endParaRPr lang="en-US"/>
+            </a:p>
+          </p:txBody>
+        </p:sp>
+        <p:sp>
+          <p:nvSpPr>
+            <p:cNvPr id="13" name="Rectangle 12">
+              <a:extLst>
+                <a:ext uri="{FF2B5EF4-FFF2-40B4-BE49-F238E27FC236}">
+                  <a16:creationId xmlns:a16="http://schemas.microsoft.com/office/drawing/2014/main" id="{34CF7C04-CC89-788D-63E2-7BD2481FABD0}"/>
+                </a:ext>
+              </a:extLst>
+            </p:cNvPr>
+            <p:cNvSpPr/>
+            <p:nvPr/>
+          </p:nvSpPr>
+          <p:spPr>
+            <a:xfrm>
+              <a:off x="3205785" y="3887003"/>
+              <a:ext cx="228235" cy="190478"/>
+            </a:xfrm>
+            <a:prstGeom prst="rect">
+              <a:avLst/>
+            </a:prstGeom>
+            <a:solidFill>
+              <a:srgbClr val="4CADD4"/>
+            </a:solidFill>
+            <a:ln w="28575">
+              <a:solidFill>
+                <a:srgbClr val="3373A0"/>
+              </a:solidFill>
+            </a:ln>
+          </p:spPr>
+          <p:style>
+            <a:lnRef idx="2">
+              <a:schemeClr val="accent1">
+                <a:shade val="50000"/>
+              </a:schemeClr>
+            </a:lnRef>
+            <a:fillRef idx="1">
+              <a:schemeClr val="accent1"/>
+            </a:fillRef>
+            <a:effectRef idx="0">
+              <a:schemeClr val="accent1"/>
+            </a:effectRef>
+            <a:fontRef idx="minor">
+              <a:schemeClr val="lt1"/>
+            </a:fontRef>
+          </p:style>
+          <p:txBody>
+            <a:bodyPr rtlCol="0" anchor="ctr"/>
+            <a:lstStyle/>
+            <a:p>
+              <a:pPr algn="ctr"/>
+              <a:endParaRPr lang="en-US" b="1">
+                <a:latin typeface="Arial" pitchFamily="34" charset="0"/>
+                <a:cs typeface="Arial" pitchFamily="34" charset="0"/>
+              </a:endParaRPr>
+            </a:p>
+          </p:txBody>
+        </p:sp>
+        <p:cxnSp>
+          <p:nvCxnSpPr>
+            <p:cNvPr id="14" name="Connector: Elbow 13">
+              <a:extLst>
+                <a:ext uri="{FF2B5EF4-FFF2-40B4-BE49-F238E27FC236}">
+                  <a16:creationId xmlns:a16="http://schemas.microsoft.com/office/drawing/2014/main" id="{204BDCF5-A325-EC83-4DA4-9195B9FC50CE}"/>
+                </a:ext>
+              </a:extLst>
+            </p:cNvPr>
+            <p:cNvCxnSpPr>
+              <a:cxnSpLocks/>
+              <a:stCxn id="13" idx="2"/>
+              <a:endCxn id="16" idx="0"/>
+            </p:cNvCxnSpPr>
+            <p:nvPr/>
+          </p:nvCxnSpPr>
+          <p:spPr>
+            <a:xfrm rot="5400000">
+              <a:off x="3194094" y="4082562"/>
+              <a:ext cx="130890" cy="120729"/>
+            </a:xfrm>
+            <a:prstGeom prst="bentConnector3">
+              <a:avLst/>
+            </a:prstGeom>
+            <a:ln w="28575">
+              <a:solidFill>
+                <a:srgbClr val="545454"/>
+              </a:solidFill>
+            </a:ln>
+          </p:spPr>
+          <p:style>
+            <a:lnRef idx="1">
+              <a:schemeClr val="accent1"/>
+            </a:lnRef>
+            <a:fillRef idx="0">
+              <a:schemeClr val="accent1"/>
+            </a:fillRef>
+            <a:effectRef idx="0">
+              <a:schemeClr val="accent1"/>
+            </a:effectRef>
+            <a:fontRef idx="minor">
+              <a:schemeClr val="tx1"/>
+            </a:fontRef>
+          </p:style>
+        </p:cxnSp>
+        <p:cxnSp>
+          <p:nvCxnSpPr>
+            <p:cNvPr id="15" name="Connector: Elbow 14">
+              <a:extLst>
+                <a:ext uri="{FF2B5EF4-FFF2-40B4-BE49-F238E27FC236}">
+                  <a16:creationId xmlns:a16="http://schemas.microsoft.com/office/drawing/2014/main" id="{66FEAA45-8090-7E68-DA1E-294F3620A719}"/>
+                </a:ext>
+              </a:extLst>
+            </p:cNvPr>
+            <p:cNvCxnSpPr>
+              <a:cxnSpLocks/>
+              <a:stCxn id="13" idx="2"/>
+              <a:endCxn id="17" idx="0"/>
+            </p:cNvCxnSpPr>
+            <p:nvPr/>
+          </p:nvCxnSpPr>
+          <p:spPr>
+            <a:xfrm rot="16200000" flipH="1">
+              <a:off x="3319027" y="4078357"/>
+              <a:ext cx="131263" cy="129510"/>
+            </a:xfrm>
+            <a:prstGeom prst="bentConnector3">
+              <a:avLst/>
+            </a:prstGeom>
+            <a:ln w="28575">
+              <a:solidFill>
+                <a:srgbClr val="545454"/>
+              </a:solidFill>
+            </a:ln>
+          </p:spPr>
+          <p:style>
+            <a:lnRef idx="1">
+              <a:schemeClr val="accent1"/>
+            </a:lnRef>
+            <a:fillRef idx="0">
+              <a:schemeClr val="accent1"/>
+            </a:fillRef>
+            <a:effectRef idx="0">
+              <a:schemeClr val="accent1"/>
+            </a:effectRef>
+            <a:fontRef idx="minor">
+              <a:schemeClr val="tx1"/>
+            </a:fontRef>
+          </p:style>
+        </p:cxnSp>
+        <p:sp>
+          <p:nvSpPr>
+            <p:cNvPr id="16" name="Rectangle 15">
+              <a:extLst>
+                <a:ext uri="{FF2B5EF4-FFF2-40B4-BE49-F238E27FC236}">
+                  <a16:creationId xmlns:a16="http://schemas.microsoft.com/office/drawing/2014/main" id="{48C525D6-B644-AC29-9048-E826ED8F57A9}"/>
+                </a:ext>
+              </a:extLst>
+            </p:cNvPr>
+            <p:cNvSpPr/>
+            <p:nvPr/>
+          </p:nvSpPr>
+          <p:spPr>
+            <a:xfrm>
+              <a:off x="3112631" y="4208371"/>
+              <a:ext cx="173086" cy="142051"/>
+            </a:xfrm>
+            <a:prstGeom prst="rect">
+              <a:avLst/>
+            </a:prstGeom>
+            <a:solidFill>
+              <a:srgbClr val="FD9962"/>
+            </a:solidFill>
+            <a:ln w="28575">
+              <a:solidFill>
+                <a:srgbClr val="AD3535"/>
+              </a:solidFill>
+            </a:ln>
+          </p:spPr>
+          <p:style>
+            <a:lnRef idx="2">
+              <a:schemeClr val="accent1">
+                <a:shade val="50000"/>
+              </a:schemeClr>
+            </a:lnRef>
+            <a:fillRef idx="1">
+              <a:schemeClr val="accent1"/>
+            </a:fillRef>
+            <a:effectRef idx="0">
+              <a:schemeClr val="accent1"/>
+            </a:effectRef>
+            <a:fontRef idx="minor">
+              <a:schemeClr val="lt1"/>
+            </a:fontRef>
+          </p:style>
+          <p:txBody>
+            <a:bodyPr rtlCol="0" anchor="ctr"/>
+            <a:lstStyle/>
+            <a:p>
+              <a:pPr algn="ctr"/>
+              <a:endParaRPr lang="en-US" b="1">
+                <a:latin typeface="Arial" pitchFamily="34" charset="0"/>
+                <a:cs typeface="Arial" pitchFamily="34" charset="0"/>
+              </a:endParaRPr>
+            </a:p>
+          </p:txBody>
+        </p:sp>
+        <p:sp>
+          <p:nvSpPr>
+            <p:cNvPr id="17" name="Rectangle 16">
+              <a:extLst>
+                <a:ext uri="{FF2B5EF4-FFF2-40B4-BE49-F238E27FC236}">
+                  <a16:creationId xmlns:a16="http://schemas.microsoft.com/office/drawing/2014/main" id="{4FE3C9E1-41FB-2CCD-9565-446106EBF062}"/>
+                </a:ext>
+              </a:extLst>
+            </p:cNvPr>
+            <p:cNvSpPr/>
+            <p:nvPr/>
+          </p:nvSpPr>
+          <p:spPr>
+            <a:xfrm>
+              <a:off x="3362870" y="4208744"/>
+              <a:ext cx="173086" cy="142051"/>
+            </a:xfrm>
+            <a:prstGeom prst="rect">
+              <a:avLst/>
+            </a:prstGeom>
+            <a:solidFill>
+              <a:srgbClr val="FD9962"/>
+            </a:solidFill>
+            <a:ln w="28575">
+              <a:solidFill>
+                <a:srgbClr val="AD3535"/>
+              </a:solidFill>
+            </a:ln>
+          </p:spPr>
+          <p:style>
+            <a:lnRef idx="2">
+              <a:schemeClr val="accent1">
+                <a:shade val="50000"/>
+              </a:schemeClr>
+            </a:lnRef>
+            <a:fillRef idx="1">
+              <a:schemeClr val="accent1"/>
+            </a:fillRef>
+            <a:effectRef idx="0">
+              <a:schemeClr val="accent1"/>
+            </a:effectRef>
+            <a:fontRef idx="minor">
+              <a:schemeClr val="lt1"/>
+            </a:fontRef>
+          </p:style>
+          <p:txBody>
+            <a:bodyPr rtlCol="0" anchor="ctr"/>
+            <a:lstStyle/>
+            <a:p>
+              <a:pPr algn="ctr"/>
+              <a:endParaRPr lang="en-US" b="1">
+                <a:latin typeface="Arial" pitchFamily="34" charset="0"/>
+                <a:cs typeface="Arial" pitchFamily="34" charset="0"/>
+              </a:endParaRPr>
+            </a:p>
+          </p:txBody>
+        </p:sp>
+      </p:grpSp>
+      <p:sp>
+        <p:nvSpPr>
+          <p:cNvPr id="7" name="Arrow: Right 6">
+            <a:extLst>
+              <a:ext uri="{FF2B5EF4-FFF2-40B4-BE49-F238E27FC236}">
+                <a16:creationId xmlns:a16="http://schemas.microsoft.com/office/drawing/2014/main" id="{7A093EE1-906D-CED0-F0CA-ABBE80043710}"/>
+              </a:ext>
+            </a:extLst>
+          </p:cNvPr>
+          <p:cNvSpPr/>
+          <p:nvPr/>
+        </p:nvSpPr>
+        <p:spPr>
+          <a:xfrm>
             <a:off x="886308" y="1054522"/>
             <a:ext cx="847673" cy="795774"/>
           </a:xfrm>
@@ -4224,7 +5201,7 @@
     </p:spTree>
     <p:extLst>
       <p:ext uri="{BB962C8B-B14F-4D97-AF65-F5344CB8AC3E}">
-        <p14:creationId xmlns:p14="http://schemas.microsoft.com/office/powerpoint/2010/main" val="98246"/>
+        <p14:creationId xmlns:p14="http://schemas.microsoft.com/office/powerpoint/2010/main" val="577907500"/>
       </p:ext>
     </p:extLst>
   </p:cSld>

</xml_diff>